<commit_message>
Corrected spelling in ABAI_P5_logbook.md and ensured Dockerfile uses Python 3.13-slim base image.
</commit_message>
<xml_diff>
--- a/P4_Auditez_un_environnement_de_donnees_bailleul_aymeric/P4_Auditez_un_environnement_de_donnees_bailleul_aymeric/ABAI_P4_01_presentation_POC.pptx
+++ b/P4_Auditez_un_environnement_de_donnees_bailleul_aymeric/P4_Auditez_un_environnement_de_donnees_bailleul_aymeric/ABAI_P4_01_presentation_POC.pptx
@@ -11663,15 +11663,18 @@
                   <a:schemeClr val="bg1"/>
                 </a:solidFill>
               </a:rPr>
-              <a:t>Explication des logs (quelle table, quelle modification…)</a:t>
-            </a:r>
-          </a:p>
-          <a:p>
-            <a:endParaRPr lang="fr-FR" sz="1000" u="sng" dirty="0">
-              <a:solidFill>
-                <a:schemeClr val="bg1"/>
-              </a:solidFill>
-            </a:endParaRPr>
+              <a:t>Explication des logs (nombres de logs par table et par actions)</a:t>
+            </a:r>
+          </a:p>
+          <a:p>
+            <a:r>
+              <a:rPr lang="fr-FR" sz="1000" u="sng" dirty="0">
+                <a:solidFill>
+                  <a:schemeClr val="bg1"/>
+                </a:solidFill>
+              </a:rPr>
+              <a:t>quelle</a:t>
+            </a:r>
           </a:p>
           <a:p>
             <a:r>
@@ -18189,6 +18192,11 @@
           </a:bodyPr>
           <a:lstStyle/>
           <a:p>
+            <a:pPr>
+              <a:buClr>
+                <a:schemeClr val="bg1"/>
+              </a:buClr>
+            </a:pPr>
             <a:r>
               <a:rPr lang="fr-FR" sz="1200" b="1" u="sng" dirty="0">
                 <a:solidFill>
@@ -18201,8 +18209,11 @@
           </a:p>
           <a:p>
             <a:pPr marL="171450" indent="-171450">
-              <a:buFontTx/>
-              <a:buChar char="-"/>
+              <a:buClr>
+                <a:schemeClr val="bg1"/>
+              </a:buClr>
+              <a:buFont typeface="Arial" panose="020B0604020202020204" pitchFamily="34" charset="0"/>
+              <a:buChar char="•"/>
             </a:pPr>
             <a:r>
               <a:rPr lang="fr-FR" sz="1000" dirty="0">
@@ -18233,6 +18244,13 @@
             </a:r>
           </a:p>
           <a:p>
+            <a:pPr marL="171450" indent="-171450">
+              <a:buClr>
+                <a:schemeClr val="bg1"/>
+              </a:buClr>
+              <a:buFont typeface="Arial" panose="020B0604020202020204" pitchFamily="34" charset="0"/>
+              <a:buChar char="•"/>
+            </a:pPr>
             <a:endParaRPr lang="fr-FR" sz="1000" dirty="0">
               <a:solidFill>
                 <a:schemeClr val="bg1"/>
@@ -18241,6 +18259,11 @@
             </a:endParaRPr>
           </a:p>
           <a:p>
+            <a:pPr>
+              <a:buClr>
+                <a:schemeClr val="bg1"/>
+              </a:buClr>
+            </a:pPr>
             <a:r>
               <a:rPr lang="fr-FR" sz="1200" b="1" u="sng" dirty="0">
                 <a:solidFill>
@@ -18253,8 +18276,11 @@
           </a:p>
           <a:p>
             <a:pPr marL="171450" indent="-171450">
-              <a:buFontTx/>
-              <a:buChar char="-"/>
+              <a:buClr>
+                <a:schemeClr val="bg1"/>
+              </a:buClr>
+              <a:buFont typeface="Arial" panose="020B0604020202020204" pitchFamily="34" charset="0"/>
+              <a:buChar char="•"/>
             </a:pPr>
             <a:r>
               <a:rPr lang="fr-FR" sz="1000" dirty="0">
@@ -18303,6 +18329,13 @@
             </a:r>
           </a:p>
           <a:p>
+            <a:pPr marL="171450" indent="-171450">
+              <a:buClr>
+                <a:schemeClr val="bg1"/>
+              </a:buClr>
+              <a:buFont typeface="Arial" panose="020B0604020202020204" pitchFamily="34" charset="0"/>
+              <a:buChar char="•"/>
+            </a:pPr>
             <a:endParaRPr lang="fr-FR" sz="1000" dirty="0">
               <a:solidFill>
                 <a:schemeClr val="bg1"/>
@@ -18311,6 +18344,11 @@
             </a:endParaRPr>
           </a:p>
           <a:p>
+            <a:pPr>
+              <a:buClr>
+                <a:schemeClr val="bg1"/>
+              </a:buClr>
+            </a:pPr>
             <a:r>
               <a:rPr lang="fr-FR" sz="1200" b="1" u="sng" dirty="0">
                 <a:solidFill>
@@ -18323,8 +18361,11 @@
           </a:p>
           <a:p>
             <a:pPr marL="171450" indent="-171450">
-              <a:buFontTx/>
-              <a:buChar char="-"/>
+              <a:buClr>
+                <a:schemeClr val="bg1"/>
+              </a:buClr>
+              <a:buFont typeface="Arial" panose="020B0604020202020204" pitchFamily="34" charset="0"/>
+              <a:buChar char="•"/>
             </a:pPr>
             <a:r>
               <a:rPr lang="fr-FR" sz="1000" dirty="0">

</xml_diff>